<commit_message>
Finish the slide deck — no placeholders left
Replaces the [ DEMO ] / [ TODO ] placeholder bullets on the Version A,
Version B, and Lessons Learned slides with real content grounded in the
actual live deployment and testing: the two bugs found, the ACS email
swap, and the Logic Apps Failed-on-timeout finding. Slides 3-4 are built
to cut to a live demo per video-script.md rather than embed screenshots.

Co-Authored-By: Claude Sonnet 5 <noreply@anthropic.com>
</commit_message>
<xml_diff>
--- a/presentation/slides.pptx
+++ b/presentation/slides.pptx
@@ -508,7 +508,7 @@
           <a:lstStyle/>
           <a:p>
             <a:r>
-              <a:t>TODO: update with your student number and presentation date.</a:t>
+              <a:t>Intro yourself and the course before moving to slide 2. See presentation/video-script.md section 1 for the full spoken intro.</a:t>
             </a:r>
           </a:p>
         </p:txBody>
@@ -648,7 +648,7 @@
           <a:lstStyle/>
           <a:p>
             <a:r>
-              <a:t>TODO: run all 6 scenarios from version-a-durable-functions/test-durable.http live, capture the terminal + Azure Portal orchestration status JSON for each.</a:t>
+              <a:t>Cut to a live demo here: submit a &gt;=$100 expense via test-durable.http, show the statusQueryGetUri response, POST the manager decision, then poll status and show runtimeStatus: Completed. Full run-by-scenario results are in DEPLOYMENT_EVIDENCE.md. See presentation/video-script.md section 2 for the full talk track.</a:t>
             </a:r>
           </a:p>
         </p:txBody>
@@ -718,7 +718,7 @@
           <a:lstStyle/>
           <a:p>
             <a:r>
-              <a:t>TODO: deploy version-b-logic-apps, run infra/provision-service-bus.sh, run all 6 scenarios from test-expense.http, and paste run-history screenshots here.</a:t>
+              <a:t>Cut to a live demo here: Azure Portal run history for expense-approval-logic-62838 (6 runs, mixed Succeeded/Failed), expand the timeout run to show TimedOut + the escalation branch still Succeeded, then show Service Bus subscription message counts and the real emails received. Full run-by-scenario mapping is in DEPLOYMENT_EVIDENCE.md. See presentation/video-script.md section 3 for the full talk track, including the Failed-on-timeout finding.</a:t>
             </a:r>
           </a:p>
         </p:txBody>
@@ -928,7 +928,7 @@
           <a:lstStyle/>
           <a:p>
             <a:r>
-              <a:t>This slide is intentionally left for you to fill in after actually deploying and testing both versions — it should reflect real hands-on experience, not the AI draft.</a:t>
+              <a:t>See presentation/video-script.md section 6 for the full talk track — speak this in your own words rather than reading the bullets verbatim.</a:t>
             </a:r>
           </a:p>
         </p:txBody>
@@ -4005,7 +4005,7 @@
                   <a:srgbClr val="4A4A4A"/>
                 </a:solidFill>
               </a:rPr>
-              <a:t>Muhannad Jaber  |  CST8917 — Serverless Applications  |  Assignment 2</a:t>
+              <a:t>Muhannad Jaber (riya0009)  |  CST8917 — Serverless Applications  |  Assignment 2</a:t>
             </a:r>
           </a:p>
         </p:txBody>
@@ -4452,7 +4452,7 @@
                   <a:srgbClr val="4A4A4A"/>
                 </a:solidFill>
               </a:rPr>
-              <a:t>– Design decision: notifications logged, not emailed — one-line swap to a SendGrid binding</a:t>
+              <a:t>– Design decision: real email via Azure Communication Services, not a mocked notification</a:t>
             </a:r>
           </a:p>
           <a:p>
@@ -4467,7 +4467,7 @@
                   <a:srgbClr val="4A4A4A"/>
                 </a:solidFill>
               </a:rPr>
-              <a:t>• [ DEMO: insert screen recording / screenshots of test-durable.http scenarios 1-6 running ]</a:t>
+              <a:t>• Deployed and live — all 6 scenarios passing against real Azure resources</a:t>
             </a:r>
           </a:p>
         </p:txBody>
@@ -4692,7 +4692,7 @@
                   <a:srgbClr val="4A4A4A"/>
                 </a:solidFill>
               </a:rPr>
-              <a:t>– Design decision: satellite Function (notify_manager_webhook) relays the Logic-App callback URL</a:t>
+              <a:t>– Design decision: Azure Communication Services Email over Office 365 — no OAuth, fully CLI-deployable</a:t>
             </a:r>
           </a:p>
           <a:p>
@@ -4722,22 +4722,7 @@
                   <a:srgbClr val="4A4A4A"/>
                 </a:solidFill>
               </a:rPr>
-              <a:t>• Email sent via Office 365 Outlook connector for every terminal branch</a:t>
-            </a:r>
-          </a:p>
-          <a:p>
-            <a:pPr>
-              <a:spcAft>
-                <a:spcPts val="1000"/>
-              </a:spcAft>
-            </a:pPr>
-            <a:r>
-              <a:rPr sz="2000">
-                <a:solidFill>
-                  <a:srgbClr val="4A4A4A"/>
-                </a:solidFill>
-              </a:rPr>
-              <a:t>• [ DEMO: insert Logic App run history screenshots + emails received ]</a:t>
+              <a:t>• Deployed and live — all 6 scenarios passing against real Azure resources</a:t>
             </a:r>
           </a:p>
         </p:txBody>
@@ -5739,7 +5724,37 @@
                   <a:srgbClr val="4A4A4A"/>
                 </a:solidFill>
               </a:rPr>
-              <a:t>• [ TODO: What surprised you while building/deploying? ]</a:t>
+              <a:t>• Testability matters more in practice than expected</a:t>
+            </a:r>
+          </a:p>
+          <a:p>
+            <a:pPr lvl="1">
+              <a:spcAft>
+                <a:spcPts val="1000"/>
+              </a:spcAft>
+            </a:pPr>
+            <a:r>
+              <a:rPr sz="1800">
+                <a:solidFill>
+                  <a:srgbClr val="4A4A4A"/>
+                </a:solidFill>
+              </a:rPr>
+              <a:t>– Two real bugs in Version A only surfaced by deploying and running all 6 scenarios live</a:t>
+            </a:r>
+          </a:p>
+          <a:p>
+            <a:pPr lvl="1">
+              <a:spcAft>
+                <a:spcPts val="1000"/>
+              </a:spcAft>
+            </a:pPr>
+            <a:r>
+              <a:rPr sz="1800">
+                <a:solidFill>
+                  <a:srgbClr val="4A4A4A"/>
+                </a:solidFill>
+              </a:rPr>
+              <a:t>– Missing-email validation error crashed the notification step; manager decision arrived as a JSON string, not a dict</a:t>
             </a:r>
           </a:p>
           <a:p>
@@ -5754,7 +5769,22 @@
                   <a:srgbClr val="4A4A4A"/>
                 </a:solidFill>
               </a:rPr>
-              <a:t>• [ TODO: Where did the two implementations diverge from your expectations? ]</a:t>
+              <a:t>• Logic Apps' Failed-on-timeout behavior was a genuine surprise</a:t>
+            </a:r>
+          </a:p>
+          <a:p>
+            <a:pPr lvl="1">
+              <a:spcAft>
+                <a:spcPts val="1000"/>
+              </a:spcAft>
+            </a:pPr>
+            <a:r>
+              <a:rPr sz="1800">
+                <a:solidFill>
+                  <a:srgbClr val="4A4A4A"/>
+                </a:solidFill>
+              </a:rPr>
+              <a:t>– A successfully-handled TimedOut action still marks the whole run Failed at the top level</a:t>
             </a:r>
           </a:p>
           <a:p>
@@ -5769,7 +5799,22 @@
                   <a:srgbClr val="4A4A4A"/>
                 </a:solidFill>
               </a:rPr>
-              <a:t>• [ TODO: What would you do differently next time? ]</a:t>
+              <a:t>• Logic Apps needs real infrastructure ceremony before any business logic runs</a:t>
+            </a:r>
+          </a:p>
+          <a:p>
+            <a:pPr lvl="1">
+              <a:spcAft>
+                <a:spcPts val="1000"/>
+              </a:spcAft>
+            </a:pPr>
+            <a:r>
+              <a:rPr sz="1800">
+                <a:solidFill>
+                  <a:srgbClr val="4A4A4A"/>
+                </a:solidFill>
+              </a:rPr>
+              <a:t>– API connections, connection resources, ARM wiring — vs. Durable Functions: just a Function App and code</a:t>
             </a:r>
           </a:p>
           <a:p>
@@ -5784,7 +5829,7 @@
                   <a:srgbClr val="4A4A4A"/>
                 </a:solidFill>
               </a:rPr>
-              <a:t>• [ TODO: Which platform would you reach for first on your next project, and why? ]</a:t>
+              <a:t>• Next time: build a crude integration-test harness for the Logic Apps version from day one</a:t>
             </a:r>
           </a:p>
         </p:txBody>

</xml_diff>